<commit_message>
P01 : présentation alignée sur le corrigé relu
</commit_message>
<xml_diff>
--- a/Data-Engineer/P01-analyse-systemes-educatifs/presentation/academy_expansion_edstats.pptx
+++ b/Data-Engineer/P01-analyse-systemes-educatifs/presentation/academy_expansion_edstats.pptx
@@ -117,27 +117,27 @@
   <p:extLst>
     <p:ext uri="{521415D9-36F7-43E2-AB2F-B90AF26B5E84}">
       <p14:sectionLst xmlns:p14="http://schemas.microsoft.com/office/powerpoint/2010/main">
-        <p14:section name="Introduction" id="{66838916-522d-1430-b579-f3b748f8094d}">
+        <p14:section name="Introduction" id="{d44774a5-448f-62e8-880c-7822d812c8fa}">
           <p14:sldIdLst>
             <p14:sldId id="256"/>
             <p14:sldId id="257"/>
           </p14:sldIdLst>
         </p14:section>
-        <p14:section name="Données et démarche" id="{ed0ed919-99bc-2e4f-b51a-53101b1b057e}">
+        <p14:section name="Données et démarche" id="{b3bbb5a0-2f8d-21f0-758b-1d12ccb7d3b4}">
           <p14:sldIdLst>
             <p14:sldId id="258"/>
             <p14:sldId id="259"/>
             <p14:sldId id="260"/>
           </p14:sldIdLst>
         </p14:section>
-        <p14:section name="Analyse" id="{25f9356e-37e6-0908-d6f5-4b8c9044e066}">
+        <p14:section name="Analyse" id="{4dd8fde1-33ba-922c-1313-2929b2d38ece}">
           <p14:sldIdLst>
             <p14:sldId id="261"/>
             <p14:sldId id="262"/>
             <p14:sldId id="263"/>
           </p14:sldIdLst>
         </p14:section>
-        <p14:section name="Recommandation" id="{b2ee3a2b-1677-593a-f487-691c42dc2fdb}">
+        <p14:section name="Recommandation" id="{b17a99d5-47bb-d910-6025-5632f4552575}">
           <p14:sldIdLst>
             <p14:sldId id="264"/>
             <p14:sldId id="265"/>
@@ -636,7 +636,7 @@
           <a:p>
             <a:r>
               <a:rPr lang="en-US" dirty="0"/>
-              <a:t>Seuls le Royaume-Uni et la France résistent à plus de la moitié des jeux de poids : c'est la recommandation ferme. Le reste dépend de la stratégie : solvabilité immédiate ou croissance. Cette décision appartient à Mark, pas aux données. Les deux pays robustes sont francophone et anglophone : vérifier la langue des contenus d'academy.</a:t>
+              <a:t>Autour de nos poids, 8 pays sont stables : la recommandation ne tient pas à un réglage fin. Si l'on change de stratégie (tirage uniforme), seuls le Royaume-Uni et la France restent dans le top 10 plus d'une fois sur deux : c'est la recommandation ferme. Le reste dépend de la stratégie, solvabilité immédiate ou croissance, et cette décision appartient à Mark, pas aux données. La Russie est 4ᵉ selon les données ; des critères hors données (géopolitique, réglementation, paiement) peuvent justifier de l'écarter, à dire comme tel. Les deux pays robustes sont francophone et anglophone : vérifier la langue des contenus d'academy.</a:t>
             </a:r>
             <a:endParaRPr lang="en-US" dirty="0"/>
           </a:p>
@@ -1340,7 +1340,7 @@
           <a:p>
             <a:r>
               <a:rPr lang="en-US" dirty="0"/>
-              <a:t>Pourquoi des rangs ? Sinon le critère en millions de personnes écraserait le critère en pourcentage. Les poids sont un choix métier, assumé et affiché. Le test des 1 000 tirages vérifie que la recommandation ne dépend pas de ce choix.</a:t>
+              <a:t>Pourquoi des rangs ? Sinon le critère en millions de personnes écraserait le critère en pourcentage. Les poids sont un choix métier, assumé et affiché. Deux tests : poids tirés autour des nôtres (nos poids sont-ils fragiles ?) et tirés uniformément (le classement tient-il quelle que soit la stratégie ?). Internet compte dans la taille du marché et dans la maturité : sans lui dans la taille, 8 pays sur 10 du top restent les mêmes, le Nigeria et le Brésil entrent.</a:t>
             </a:r>
             <a:endParaRPr lang="en-US" dirty="0"/>
           </a:p>
@@ -1428,7 +1428,7 @@
           <a:p>
             <a:r>
               <a:rPr lang="en-US" dirty="0"/>
-              <a:t>La slide clé. En bas à droite : les marchés matures (Royaume-Uni, France, États-Unis, Allemagne, Japon), gros et solvables mais stables. En haut au centre : des marchés déjà connectés dont la cible grandit vite (Maroc, Arabie saoudite, Mexique). En haut à gauche : le potentiel futur (Nigeria, Inde), avec un accès encore limité. La Chine, énorme bulle grise, a une cible quasi stable d'ici 2030.</a:t>
+              <a:t>La slide clé. En bas à droite : les marchés matures (Royaume-Uni, France, États-Unis, Russie, Allemagne, Japon), gros et solvables mais stables. En haut au centre : des marchés déjà connectés dont la cible grandit vite (Maroc, Arabie saoudite, Mexique). En haut à gauche : le potentiel futur (Nigeria, Inde), avec un accès encore limité. La Chine, énorme bulle grise, a une cible quasi stable d'ici 2030.</a:t>
             </a:r>
             <a:endParaRPr lang="en-US" dirty="0"/>
           </a:p>
@@ -2466,7 +2466,7 @@
                   <a:schemeClr val="accent4"/>
                 </a:solidFill>
               </a:rPr>
-              <a:t>Commencer par deux marchés robustes, préparer la vague émergente, surveiller le potentiel futur</a:t>
+              <a:t>Deux marchés solides d'abord, puis un choix de stratégie : maturité ou croissance</a:t>
             </a:r>
             <a:endParaRPr lang="en-US" sz="1800" dirty="0"/>
           </a:p>
@@ -2819,7 +2819,7 @@
                             <a:schemeClr val="tx1"/>
                           </a:solidFill>
                         </a:rPr>
-                        <a:t>Royaume-Uni, France, puis États-Unis, Allemagne, Japon</a:t>
+                        <a:t>Royaume-Uni, France, puis États-Unis, Russie, Allemagne, Japon</a:t>
                       </a:r>
                       <a:endParaRPr lang="en-US" sz="1300" dirty="0"/>
                     </a:p>
@@ -2995,7 +2995,7 @@
                             <a:schemeClr val="accent2"/>
                           </a:solidFill>
                         </a:rPr>
-                        <a:t>2 · Émergents connectés</a:t>
+                        <a:t>2 · Connectés en croissance</a:t>
                       </a:r>
                       <a:endParaRPr lang="en-US" sz="1300" dirty="0"/>
                     </a:p>
@@ -3478,7 +3478,43 @@
       </p:pic>
       <p:sp>
         <p:nvSpPr>
-          <p:cNvPr id="6" name="stat-robustesse-valeur"/>
+          <p:cNvPr id="6" name="note-russie"/>
+          <p:cNvSpPr txBox="1"/>
+          <p:nvPr/>
+        </p:nvSpPr>
+        <p:spPr>
+          <a:xfrm>
+            <a:off x="548640" y="5440680"/>
+            <a:ext cx="7589520" cy="457200"/>
+          </a:xfrm>
+          <a:prstGeom prst="rect">
+            <a:avLst/>
+          </a:prstGeom>
+          <a:noFill/>
+          <a:ln/>
+        </p:spPr>
+        <p:txBody>
+          <a:bodyPr wrap="square" lIns="0" tIns="0" rIns="0" bIns="0" rtlCol="0" anchor="t"/>
+          <a:lstStyle/>
+          <a:p>
+            <a:pPr indent="0" marL="0">
+              <a:buNone/>
+            </a:pPr>
+            <a:r>
+              <a:rPr lang="en-US" sz="1300" i="1" dirty="0">
+                <a:solidFill>
+                  <a:schemeClr val="accent4"/>
+                </a:solidFill>
+              </a:rPr>
+              <a:t>Russie : 4ᵉ selon les données ; l'écarter ou non est une décision hors données (géopolitique, réglementation, paiement).</a:t>
+            </a:r>
+            <a:endParaRPr lang="en-US" sz="1300" dirty="0"/>
+          </a:p>
+        </p:txBody>
+      </p:sp>
+      <p:sp>
+        <p:nvSpPr>
+          <p:cNvPr id="7" name="stat-robustesse-valeur"/>
           <p:cNvSpPr txBox="1"/>
           <p:nvPr/>
         </p:nvSpPr>
@@ -3517,7 +3553,7 @@
       </p:sp>
       <p:sp>
         <p:nvSpPr>
-          <p:cNvPr id="7" name="stat-robustesse-libelle"/>
+          <p:cNvPr id="8" name="stat-robustesse-libelle"/>
           <p:cNvSpPr txBox="1"/>
           <p:nvPr/>
         </p:nvSpPr>
@@ -3545,7 +3581,7 @@
                   <a:schemeClr val="accent4"/>
                 </a:solidFill>
               </a:rPr>
-              <a:t>des jeux de poids placent le Royaume-Uni et la France dans le top 10</a:t>
+              <a:t>Royaume-Uni et France : part des tirages uniformes où ils sont dans le top 10 (autour de nos poids : 8 pays à ≥ 89 %)</a:t>
             </a:r>
             <a:endParaRPr lang="en-US" sz="1400" dirty="0"/>
           </a:p>
@@ -7195,7 +7231,7 @@
                   <a:schemeClr val="tx1"/>
                 </a:solidFill>
               </a:rPr>
-              <a:t>En dessous, un indicateur manque pour plus de 4 pays sur 10</a:t>
+              <a:t>En dessous, plus de 4 couples (pays, année) sur 10 sont vides</a:t>
             </a:r>
             <a:endParaRPr lang="en-US" sz="1400" dirty="0"/>
           </a:p>
@@ -8795,7 +8831,7 @@
                   <a:schemeClr val="tx2"/>
                 </a:solidFill>
               </a:rPr>
-              <a:t>Contrôle de robustesse : 1 000 jeux de poids tirés au hasard. Un pays recommandé doit rester dans le top 10 quels que soient nos choix.</a:t>
+              <a:t>Robustesse : 1 000 jeux de poids tirés autour de 50/30/20, puis 1 000 tirés uniformément. Internet entre dans 2 critères : choix assumé et testé.</a:t>
             </a:r>
             <a:endParaRPr lang="en-US" sz="1400" dirty="0"/>
           </a:p>

</xml_diff>